<commit_message>
docs: update presentation slides and PPTX with 39 passing tests and rubric details
</commit_message>
<xml_diff>
--- a/docs/Review1_Presentation.pptx
+++ b/docs/Review1_Presentation.pptx
@@ -2592,7 +2592,7 @@
                 <a:ea typeface="Arial" pitchFamily="34" charset="-122"/>
                 <a:cs typeface="Arial" pitchFamily="34" charset="-120"/>
               </a:rPr>
-              <a:t>19/19 Passed</a:t>
+              <a:t>39/39 Passed</a:t>
             </a:r>
             <a:endParaRPr lang="en-US" sz="1800" dirty="0"/>
           </a:p>
@@ -3251,7 +3251,7 @@
                 <a:ea typeface="Arial" pitchFamily="34" charset="-122"/>
                 <a:cs typeface="Arial" pitchFamily="34" charset="-120"/>
               </a:rPr>
-              <a:t>CoreJavaOopTest (4 Tests)</a:t>
+              <a:t>CoreJavaOopTest (8 Tests)</a:t>
             </a:r>
             <a:endParaRPr lang="en-US" sz="1500" dirty="0"/>
           </a:p>
@@ -3349,7 +3349,7 @@
                 <a:ea typeface="Arial" pitchFamily="34" charset="-122"/>
                 <a:cs typeface="Arial" pitchFamily="34" charset="-120"/>
               </a:rPr>
-              <a:t>Verifies encapsulation accessors, Student/Instructor/Admin inheritance, runtime polymorphic strategy calculations, and custom LmsException behaviors.</a:t>
+              <a:t>Verifies encapsulation accessors, Student/Instructor/Admin inheritance, runtime polymorphic strategy calculations, Comparable, and custom LmsException behaviors.</a:t>
             </a:r>
             <a:endParaRPr lang="en-US" sz="1200" dirty="0"/>
           </a:p>
@@ -3413,7 +3413,7 @@
                 <a:ea typeface="Arial" pitchFamily="34" charset="-122"/>
                 <a:cs typeface="Arial" pitchFamily="34" charset="-120"/>
               </a:rPr>
-              <a:t>JdbcDaoPersistenceTest (4 Tests)</a:t>
+              <a:t>JdbcDaoPersistenceTest (6 Tests)</a:t>
             </a:r>
             <a:endParaRPr lang="en-US" sz="1500" dirty="0"/>
           </a:p>
@@ -3575,7 +3575,7 @@
                 <a:ea typeface="Arial" pitchFamily="34" charset="-122"/>
                 <a:cs typeface="Arial" pitchFamily="34" charset="-120"/>
               </a:rPr>
-              <a:t>ServiceTransactionTest (6 Tests)</a:t>
+              <a:t>ServiceTransactionTest (12 Tests)</a:t>
             </a:r>
             <a:endParaRPr lang="en-US" sz="1500" dirty="0"/>
           </a:p>
@@ -3673,7 +3673,7 @@
                 <a:ea typeface="Arial" pitchFamily="34" charset="-122"/>
                 <a:cs typeface="Arial" pitchFamily="34" charset="-120"/>
               </a:rPr>
-              <a:t>Verifies TransactionManager execution, rollback suppression, conditional capacity enforcement (CourseFullException), and symmetric dropCourse.</a:t>
+              <a:t>Verifies TransactionManager execution, 20-thread concurrency test (0 oversells), rollback suppression, capacity enforcement, and symmetric dropCourse.</a:t>
             </a:r>
             <a:endParaRPr lang="en-US" sz="1200" dirty="0"/>
           </a:p>
@@ -3737,7 +3737,7 @@
                 <a:ea typeface="Arial" pitchFamily="34" charset="-122"/>
                 <a:cs typeface="Arial" pitchFamily="34" charset="-120"/>
               </a:rPr>
-              <a:t>ServletRequestHandlingTest (4 Tests)</a:t>
+              <a:t>ServletRequestHandlingTest (13 Tests)</a:t>
             </a:r>
             <a:endParaRPr lang="en-US" sz="1500" dirty="0"/>
           </a:p>
@@ -3835,7 +3835,7 @@
                 <a:ea typeface="Arial" pitchFamily="34" charset="-122"/>
                 <a:cs typeface="Arial" pitchFamily="34" charset="-120"/>
               </a:rPr>
-              <a:t>Tests BaseServlet JSON response dispatching, standard HTTP response envelopes, and error handling for unauthorized requests.</a:t>
+              <a:t>Tests BaseServlet JSON response dispatching, AuthFilter role-based access control, and error handling for unauthorized requests (400, 401, 403, 404, 409, 415).</a:t>
             </a:r>
             <a:endParaRPr lang="en-US" sz="1200" dirty="0"/>
           </a:p>
@@ -4279,7 +4279,7 @@
                   <a:srgbClr val="94A3B8"/>
                 </a:solidFill>
               </a:rPr>
-              <a:t>Application is currently live on port 8080 and backed by 19 passing automated tests.
+              <a:t>Application is currently live on port 8080 and backed by 39 passing automated tests.
 </a:t>
             </a:r>
             <a:pPr indent="0" marL="0">

</xml_diff>

<commit_message>
docs: add team leader and member to presentation deliverables
</commit_message>
<xml_diff>
--- a/docs/Review1_Presentation.pptx
+++ b/docs/Review1_Presentation.pptx
@@ -2067,17 +2067,17 @@
               <a:buNone/>
             </a:pPr>
             <a:r>
-              <a:rPr lang="en-US" sz="1100" dirty="0">
-                <a:solidFill>
-                  <a:srgbClr val="94A3B8"/>
-                </a:solidFill>
-                <a:latin typeface="Arial" pitchFamily="34" charset="0"/>
-                <a:ea typeface="Arial" pitchFamily="34" charset="-122"/>
-                <a:cs typeface="Arial" pitchFamily="34" charset="-120"/>
-              </a:rPr>
-              <a:t>Team: 3rd Sem CSE Batch | Technologies: Java 17+, Jakarta Servlets 6.0, Tomcat 10.1, JDBC, HikariCP, React 18</a:t>
-            </a:r>
-            <a:endParaRPr lang="en-US" sz="1100" dirty="0"/>
+              <a:rPr lang="en-US" sz="1200" b="1" dirty="0">
+                <a:solidFill>
+                  <a:srgbClr val="10B981"/>
+                </a:solidFill>
+                <a:latin typeface="Arial" pitchFamily="34" charset="0"/>
+                <a:ea typeface="Arial" pitchFamily="34" charset="-122"/>
+                <a:cs typeface="Arial" pitchFamily="34" charset="-120"/>
+              </a:rPr>
+              <a:t>Team - Abhinav Kumar Singh (Leader), Akash Yadav(Member). | Java 17+, Jakarta Servlets 6.0, JDBC, Tomcat 10.1, React 18</a:t>
+            </a:r>
+            <a:endParaRPr lang="en-US" sz="1200" dirty="0"/>
           </a:p>
         </p:txBody>
       </p:sp>

</xml_diff>